<commit_message>
Update SmartVision presentation file for final capstone project
</commit_message>
<xml_diff>
--- a/docs/capstone-docs/Final Capstone project (May 13th) /powerpoint/SmartVision.pptx
+++ b/docs/capstone-docs/Final Capstone project (May 13th) /powerpoint/SmartVision.pptx
@@ -104,6 +104,11 @@
       </a:defRPr>
     </a:lvl9pPr>
   </p:defaultTextStyle>
+  <p:extLst>
+    <p:ext uri="{EFAFB233-063F-42B5-8137-9DF3F51BA10A}">
+      <p15:sldGuideLst xmlns:p15="http://schemas.microsoft.com/office/powerpoint/2012/main"/>
+    </p:ext>
+  </p:extLst>
 </p:presentation>
 </file>
 
@@ -1319,7 +1324,7 @@
             <a:fld id="{9334D819-9F07-4261-B09B-9E467E5D9002}" type="datetimeFigureOut">
               <a:rPr lang="en-US" dirty="0"/>
               <a:pPr/>
-              <a:t>5/8/25</a:t>
+              <a:t>5/10/25</a:t>
             </a:fld>
             <a:endParaRPr lang="en-US" dirty="0"/>
           </a:p>
@@ -1553,7 +1558,7 @@
           <a:p>
             <a:fld id="{9334D819-9F07-4261-B09B-9E467E5D9002}" type="datetimeFigureOut">
               <a:rPr lang="en-US" dirty="0"/>
-              <a:t>5/8/25</a:t>
+              <a:t>5/10/25</a:t>
             </a:fld>
             <a:endParaRPr lang="en-US" dirty="0"/>
           </a:p>
@@ -1728,7 +1733,7 @@
           <a:p>
             <a:fld id="{9334D819-9F07-4261-B09B-9E467E5D9002}" type="datetimeFigureOut">
               <a:rPr lang="en-US" dirty="0"/>
-              <a:t>5/8/25</a:t>
+              <a:t>5/10/25</a:t>
             </a:fld>
             <a:endParaRPr lang="en-US" dirty="0"/>
           </a:p>
@@ -1893,7 +1898,7 @@
           <a:p>
             <a:fld id="{9334D819-9F07-4261-B09B-9E467E5D9002}" type="datetimeFigureOut">
               <a:rPr lang="en-US" dirty="0"/>
-              <a:t>5/8/25</a:t>
+              <a:t>5/10/25</a:t>
             </a:fld>
             <a:endParaRPr lang="en-US" dirty="0"/>
           </a:p>
@@ -2165,7 +2170,7 @@
             <a:fld id="{9334D819-9F07-4261-B09B-9E467E5D9002}" type="datetimeFigureOut">
               <a:rPr lang="en-US" dirty="0"/>
               <a:pPr/>
-              <a:t>5/8/25</a:t>
+              <a:t>5/10/25</a:t>
             </a:fld>
             <a:endParaRPr lang="en-US" dirty="0"/>
           </a:p>
@@ -3362,7 +3367,7 @@
           <a:p>
             <a:fld id="{9334D819-9F07-4261-B09B-9E467E5D9002}" type="datetimeFigureOut">
               <a:rPr lang="en-US" dirty="0"/>
-              <a:t>5/8/25</a:t>
+              <a:t>5/10/25</a:t>
             </a:fld>
             <a:endParaRPr lang="en-US" dirty="0"/>
           </a:p>
@@ -3747,7 +3752,7 @@
           <a:p>
             <a:fld id="{9334D819-9F07-4261-B09B-9E467E5D9002}" type="datetimeFigureOut">
               <a:rPr lang="en-US" dirty="0"/>
-              <a:t>5/8/25</a:t>
+              <a:t>5/10/25</a:t>
             </a:fld>
             <a:endParaRPr lang="en-US" dirty="0"/>
           </a:p>
@@ -3865,7 +3870,7 @@
           <a:p>
             <a:fld id="{9334D819-9F07-4261-B09B-9E467E5D9002}" type="datetimeFigureOut">
               <a:rPr lang="en-US" dirty="0"/>
-              <a:t>5/8/25</a:t>
+              <a:t>5/10/25</a:t>
             </a:fld>
             <a:endParaRPr lang="en-US" dirty="0"/>
           </a:p>
@@ -3955,7 +3960,7 @@
           <a:p>
             <a:fld id="{9334D819-9F07-4261-B09B-9E467E5D9002}" type="datetimeFigureOut">
               <a:rPr lang="en-US" dirty="0"/>
-              <a:t>5/8/25</a:t>
+              <a:t>5/10/25</a:t>
             </a:fld>
             <a:endParaRPr lang="en-US" dirty="0"/>
           </a:p>
@@ -4713,7 +4718,7 @@
           <a:p>
             <a:fld id="{9334D819-9F07-4261-B09B-9E467E5D9002}" type="datetimeFigureOut">
               <a:rPr lang="en-US" dirty="0"/>
-              <a:t>5/8/25</a:t>
+              <a:t>5/10/25</a:t>
             </a:fld>
             <a:endParaRPr lang="en-US" dirty="0"/>
           </a:p>
@@ -5548,7 +5553,7 @@
           <a:p>
             <a:fld id="{9334D819-9F07-4261-B09B-9E467E5D9002}" type="datetimeFigureOut">
               <a:rPr lang="en-US" dirty="0"/>
-              <a:t>5/8/25</a:t>
+              <a:t>5/10/25</a:t>
             </a:fld>
             <a:endParaRPr lang="en-US" dirty="0"/>
           </a:p>
@@ -5771,7 +5776,7 @@
             <a:fld id="{9334D819-9F07-4261-B09B-9E467E5D9002}" type="datetimeFigureOut">
               <a:rPr lang="en-US" dirty="0"/>
               <a:pPr/>
-              <a:t>5/8/25</a:t>
+              <a:t>5/10/25</a:t>
             </a:fld>
             <a:endParaRPr lang="en-US" dirty="0"/>
           </a:p>
@@ -6787,7 +6792,10 @@
           <a:bodyPr/>
           <a:lstStyle/>
           <a:p>
-            <a:endParaRPr lang="en-US"/>
+            <a:r>
+              <a:rPr lang="en-US" dirty="0"/>
+              <a:t>SmartVision</a:t>
+            </a:r>
           </a:p>
         </p:txBody>
       </p:sp>
@@ -6812,7 +6820,18 @@
           <a:bodyPr/>
           <a:lstStyle/>
           <a:p>
-            <a:endParaRPr lang="en-US"/>
+            <a:r>
+              <a:rPr lang="en-US" dirty="0"/>
+              <a:t>The computer vision robot named “</a:t>
+            </a:r>
+            <a:r>
+              <a:rPr lang="en-US" dirty="0" err="1"/>
+              <a:t>doffy</a:t>
+            </a:r>
+            <a:r>
+              <a:rPr lang="en-US"/>
+              <a:t>”</a:t>
+            </a:r>
           </a:p>
         </p:txBody>
       </p:sp>

</xml_diff>

<commit_message>
Add new video files for color detection functionality implementation
</commit_message>
<xml_diff>
--- a/docs/capstone-docs/Final Capstone project (May 13th) /powerpoint/SmartVision.pptx
+++ b/docs/capstone-docs/Final Capstone project (May 13th) /powerpoint/SmartVision.pptx
@@ -6,6 +6,9 @@
   </p:sldMasterIdLst>
   <p:sldIdLst>
     <p:sldId id="256" r:id="rId2"/>
+    <p:sldId id="259" r:id="rId3"/>
+    <p:sldId id="257" r:id="rId4"/>
+    <p:sldId id="258" r:id="rId5"/>
   </p:sldIdLst>
   <p:sldSz cx="12192000" cy="6858000"/>
   <p:notesSz cx="6858000" cy="9144000"/>
@@ -6829,7 +6832,7 @@
               <a:t>doffy</a:t>
             </a:r>
             <a:r>
-              <a:rPr lang="en-US"/>
+              <a:rPr lang="en-US" dirty="0"/>
               <a:t>”</a:t>
             </a:r>
           </a:p>
@@ -6839,6 +6842,292 @@
     <p:extLst>
       <p:ext uri="{BB962C8B-B14F-4D97-AF65-F5344CB8AC3E}">
         <p14:creationId xmlns:p14="http://schemas.microsoft.com/office/powerpoint/2010/main" val="1087553723"/>
+      </p:ext>
+    </p:extLst>
+  </p:cSld>
+  <p:clrMapOvr>
+    <a:masterClrMapping/>
+  </p:clrMapOvr>
+</p:sld>
+</file>
+
+<file path=ppt/slides/slide2.xml><?xml version="1.0" encoding="utf-8"?>
+<p:sld xmlns:a="http://schemas.openxmlformats.org/drawingml/2006/main" xmlns:r="http://schemas.openxmlformats.org/officeDocument/2006/relationships" xmlns:p="http://schemas.openxmlformats.org/presentationml/2006/main">
+  <p:cSld>
+    <p:spTree>
+      <p:nvGrpSpPr>
+        <p:cNvPr id="1" name=""/>
+        <p:cNvGrpSpPr/>
+        <p:nvPr/>
+      </p:nvGrpSpPr>
+      <p:grpSpPr>
+        <a:xfrm>
+          <a:off x="0" y="0"/>
+          <a:ext cx="0" cy="0"/>
+          <a:chOff x="0" y="0"/>
+          <a:chExt cx="0" cy="0"/>
+        </a:xfrm>
+      </p:grpSpPr>
+      <p:sp>
+        <p:nvSpPr>
+          <p:cNvPr id="2" name="Title 1">
+            <a:extLst>
+              <a:ext uri="{FF2B5EF4-FFF2-40B4-BE49-F238E27FC236}">
+                <a16:creationId xmlns:a16="http://schemas.microsoft.com/office/drawing/2014/main" id="{39FF2877-B96D-470B-9F04-46B5415D8CA9}"/>
+              </a:ext>
+            </a:extLst>
+          </p:cNvPr>
+          <p:cNvSpPr>
+            <a:spLocks noGrp="1"/>
+          </p:cNvSpPr>
+          <p:nvPr>
+            <p:ph type="title"/>
+          </p:nvPr>
+        </p:nvSpPr>
+        <p:spPr/>
+        <p:txBody>
+          <a:bodyPr/>
+          <a:lstStyle/>
+          <a:p>
+            <a:r>
+              <a:rPr lang="en-US" dirty="0"/>
+              <a:t>INTRODUCTION	</a:t>
+            </a:r>
+          </a:p>
+        </p:txBody>
+      </p:sp>
+      <p:sp>
+        <p:nvSpPr>
+          <p:cNvPr id="3" name="Content Placeholder 2">
+            <a:extLst>
+              <a:ext uri="{FF2B5EF4-FFF2-40B4-BE49-F238E27FC236}">
+                <a16:creationId xmlns:a16="http://schemas.microsoft.com/office/drawing/2014/main" id="{8BD13DFE-54A5-267F-DC35-AA341543B9FC}"/>
+              </a:ext>
+            </a:extLst>
+          </p:cNvPr>
+          <p:cNvSpPr>
+            <a:spLocks noGrp="1"/>
+          </p:cNvSpPr>
+          <p:nvPr>
+            <p:ph idx="1"/>
+          </p:nvPr>
+        </p:nvSpPr>
+        <p:spPr/>
+        <p:txBody>
+          <a:bodyPr/>
+          <a:lstStyle/>
+          <a:p>
+            <a:endParaRPr lang="en-US" dirty="0"/>
+          </a:p>
+        </p:txBody>
+      </p:sp>
+      <p:sp>
+        <p:nvSpPr>
+          <p:cNvPr id="4" name="Text Placeholder 3">
+            <a:extLst>
+              <a:ext uri="{FF2B5EF4-FFF2-40B4-BE49-F238E27FC236}">
+                <a16:creationId xmlns:a16="http://schemas.microsoft.com/office/drawing/2014/main" id="{CA73E8CC-BEB2-F314-88BC-92888626996E}"/>
+              </a:ext>
+            </a:extLst>
+          </p:cNvPr>
+          <p:cNvSpPr>
+            <a:spLocks noGrp="1"/>
+          </p:cNvSpPr>
+          <p:nvPr>
+            <p:ph type="body" sz="half" idx="2"/>
+          </p:nvPr>
+        </p:nvSpPr>
+        <p:spPr/>
+        <p:txBody>
+          <a:bodyPr/>
+          <a:lstStyle/>
+          <a:p>
+            <a:endParaRPr lang="en-US" dirty="0"/>
+          </a:p>
+        </p:txBody>
+      </p:sp>
+    </p:spTree>
+    <p:extLst>
+      <p:ext uri="{BB962C8B-B14F-4D97-AF65-F5344CB8AC3E}">
+        <p14:creationId xmlns:p14="http://schemas.microsoft.com/office/powerpoint/2010/main" val="655874283"/>
+      </p:ext>
+    </p:extLst>
+  </p:cSld>
+  <p:clrMapOvr>
+    <a:masterClrMapping/>
+  </p:clrMapOvr>
+</p:sld>
+</file>
+
+<file path=ppt/slides/slide3.xml><?xml version="1.0" encoding="utf-8"?>
+<p:sld xmlns:a="http://schemas.openxmlformats.org/drawingml/2006/main" xmlns:r="http://schemas.openxmlformats.org/officeDocument/2006/relationships" xmlns:p="http://schemas.openxmlformats.org/presentationml/2006/main">
+  <p:cSld>
+    <p:spTree>
+      <p:nvGrpSpPr>
+        <p:cNvPr id="1" name=""/>
+        <p:cNvGrpSpPr/>
+        <p:nvPr/>
+      </p:nvGrpSpPr>
+      <p:grpSpPr>
+        <a:xfrm>
+          <a:off x="0" y="0"/>
+          <a:ext cx="0" cy="0"/>
+          <a:chOff x="0" y="0"/>
+          <a:chExt cx="0" cy="0"/>
+        </a:xfrm>
+      </p:grpSpPr>
+      <p:sp>
+        <p:nvSpPr>
+          <p:cNvPr id="2" name="Title 1">
+            <a:extLst>
+              <a:ext uri="{FF2B5EF4-FFF2-40B4-BE49-F238E27FC236}">
+                <a16:creationId xmlns:a16="http://schemas.microsoft.com/office/drawing/2014/main" id="{BDC4C734-2B1C-68A3-99B6-EE0AC9331793}"/>
+              </a:ext>
+            </a:extLst>
+          </p:cNvPr>
+          <p:cNvSpPr>
+            <a:spLocks noGrp="1"/>
+          </p:cNvSpPr>
+          <p:nvPr>
+            <p:ph type="title"/>
+          </p:nvPr>
+        </p:nvSpPr>
+        <p:spPr/>
+        <p:txBody>
+          <a:bodyPr/>
+          <a:lstStyle/>
+          <a:p>
+            <a:r>
+              <a:rPr lang="en-US" dirty="0"/>
+              <a:t>Introduction	</a:t>
+            </a:r>
+          </a:p>
+        </p:txBody>
+      </p:sp>
+      <p:sp>
+        <p:nvSpPr>
+          <p:cNvPr id="3" name="Content Placeholder 2">
+            <a:extLst>
+              <a:ext uri="{FF2B5EF4-FFF2-40B4-BE49-F238E27FC236}">
+                <a16:creationId xmlns:a16="http://schemas.microsoft.com/office/drawing/2014/main" id="{BB10A893-1A7B-DBC4-AC1C-53D1A1BBE96A}"/>
+              </a:ext>
+            </a:extLst>
+          </p:cNvPr>
+          <p:cNvSpPr>
+            <a:spLocks noGrp="1"/>
+          </p:cNvSpPr>
+          <p:nvPr>
+            <p:ph idx="1"/>
+          </p:nvPr>
+        </p:nvSpPr>
+        <p:spPr/>
+        <p:txBody>
+          <a:bodyPr/>
+          <a:lstStyle/>
+          <a:p>
+            <a:pPr algn="l">
+              <a:buNone/>
+            </a:pPr>
+            <a:r>
+              <a:rPr lang="en-US" b="0" i="0" u="none" strike="noStrike" dirty="0">
+                <a:effectLst/>
+                <a:latin typeface="fkGroteskNeue"/>
+              </a:rPr>
+              <a:t>SmartVision is an open-source, modular robotic vision system built on the Raspberry Pi platform, integrating a robotic arm and modern computer vision/machine learning frameworks. The project’s goal is to bridge the gap between theory and hands-on learning in computer vision, providing a practical, affordable, and extensible platform for students, educators, and makers.</a:t>
+            </a:r>
+          </a:p>
+          <a:p>
+            <a:pPr>
+              <a:buNone/>
+            </a:pPr>
+            <a:endParaRPr lang="en-US" dirty="0"/>
+          </a:p>
+        </p:txBody>
+      </p:sp>
+    </p:spTree>
+    <p:extLst>
+      <p:ext uri="{BB962C8B-B14F-4D97-AF65-F5344CB8AC3E}">
+        <p14:creationId xmlns:p14="http://schemas.microsoft.com/office/powerpoint/2010/main" val="2390842821"/>
+      </p:ext>
+    </p:extLst>
+  </p:cSld>
+  <p:clrMapOvr>
+    <a:masterClrMapping/>
+  </p:clrMapOvr>
+</p:sld>
+</file>
+
+<file path=ppt/slides/slide4.xml><?xml version="1.0" encoding="utf-8"?>
+<p:sld xmlns:a="http://schemas.openxmlformats.org/drawingml/2006/main" xmlns:r="http://schemas.openxmlformats.org/officeDocument/2006/relationships" xmlns:p="http://schemas.openxmlformats.org/presentationml/2006/main">
+  <p:cSld>
+    <p:spTree>
+      <p:nvGrpSpPr>
+        <p:cNvPr id="1" name=""/>
+        <p:cNvGrpSpPr/>
+        <p:nvPr/>
+      </p:nvGrpSpPr>
+      <p:grpSpPr>
+        <a:xfrm>
+          <a:off x="0" y="0"/>
+          <a:ext cx="0" cy="0"/>
+          <a:chOff x="0" y="0"/>
+          <a:chExt cx="0" cy="0"/>
+        </a:xfrm>
+      </p:grpSpPr>
+      <p:sp>
+        <p:nvSpPr>
+          <p:cNvPr id="2" name="Title 1">
+            <a:extLst>
+              <a:ext uri="{FF2B5EF4-FFF2-40B4-BE49-F238E27FC236}">
+                <a16:creationId xmlns:a16="http://schemas.microsoft.com/office/drawing/2014/main" id="{7314D490-EE6E-5790-B08E-4B0D9EA83A6C}"/>
+              </a:ext>
+            </a:extLst>
+          </p:cNvPr>
+          <p:cNvSpPr>
+            <a:spLocks noGrp="1"/>
+          </p:cNvSpPr>
+          <p:nvPr>
+            <p:ph type="title"/>
+          </p:nvPr>
+        </p:nvSpPr>
+        <p:spPr/>
+        <p:txBody>
+          <a:bodyPr/>
+          <a:lstStyle/>
+          <a:p>
+            <a:endParaRPr lang="en-US"/>
+          </a:p>
+        </p:txBody>
+      </p:sp>
+      <p:sp>
+        <p:nvSpPr>
+          <p:cNvPr id="3" name="Content Placeholder 2">
+            <a:extLst>
+              <a:ext uri="{FF2B5EF4-FFF2-40B4-BE49-F238E27FC236}">
+                <a16:creationId xmlns:a16="http://schemas.microsoft.com/office/drawing/2014/main" id="{C48A2A4F-49BA-0FE4-5310-DDDE9B4FEF68}"/>
+              </a:ext>
+            </a:extLst>
+          </p:cNvPr>
+          <p:cNvSpPr>
+            <a:spLocks noGrp="1"/>
+          </p:cNvSpPr>
+          <p:nvPr>
+            <p:ph idx="1"/>
+          </p:nvPr>
+        </p:nvSpPr>
+        <p:spPr/>
+        <p:txBody>
+          <a:bodyPr/>
+          <a:lstStyle/>
+          <a:p>
+            <a:endParaRPr lang="en-US"/>
+          </a:p>
+        </p:txBody>
+      </p:sp>
+    </p:spTree>
+    <p:extLst>
+      <p:ext uri="{BB962C8B-B14F-4D97-AF65-F5344CB8AC3E}">
+        <p14:creationId xmlns:p14="http://schemas.microsoft.com/office/powerpoint/2010/main" val="3676585368"/>
       </p:ext>
     </p:extLst>
   </p:cSld>

</xml_diff>